<commit_message>
chore(style): enforce no em dash rule with CI and prebuild (#13)
Replace U+2014 across docs, autoagents, presentations, and nginx.
Add check-no-em-dash script, npm prebuild hook, GitHub Actions, and CONTRIBUTING.md.
Bump site version to 1.1.22.

Co-authored-by: Cursor <cursoragent@cursor.com>
</commit_message>
<xml_diff>
--- a/presentations/KM0-Impacto-Digital-ES.pptx
+++ b/presentations/KM0-Impacto-Digital-ES.pptx
@@ -4098,7 +4098,7 @@
               </a:defRPr>
             </a:pPr>
             <a:r>
-              <a:t>Encuentro de visión en Masnou — por qué y para quién</a:t>
+              <a:t>Encuentro de visión en Masnou: por qué y para quién</a:t>
             </a:r>
           </a:p>
         </p:txBody>
@@ -4809,7 +4809,7 @@
               </a:defRPr>
             </a:pPr>
             <a:r>
-              <a:t>Servicios abiertos, cercanos y sostenibles — no otro proveedor más</a:t>
+              <a:t>Servicios abiertos, cercanos y sostenibles, no otro proveedor más</a:t>
             </a:r>
           </a:p>
           <a:p>
@@ -5835,7 +5835,7 @@
               </a:defRPr>
             </a:pPr>
             <a:r>
-              <a:t>KM0 Cloud — ya en producción</a:t>
+              <a:t>KM0 Cloud, ya en producción</a:t>
             </a:r>
           </a:p>
         </p:txBody>
@@ -6134,7 +6134,7 @@
               </a:defRPr>
             </a:pPr>
             <a:r>
-              <a:t>OpenCloud — la plataforma abierta</a:t>
+              <a:t>OpenCloud, la plataforma abierta</a:t>
             </a:r>
           </a:p>
         </p:txBody>
@@ -6911,7 +6911,7 @@
               </a:defRPr>
             </a:pPr>
             <a:r>
-              <a:t>Operado por AMVARA CONSULTING S.L. — certificado ISO/IEC 27001:2022</a:t>
+              <a:t>Operado por AMVARA CONSULTING S.L., certificado ISO/IEC 27001:2022</a:t>
             </a:r>
           </a:p>
           <a:p>

</xml_diff>